<commit_message>
Go-live: checklist, transfer guide, refreshed manual and deck, image v1.3 label
Co-Authored-By: Claude Sonnet 5.5 <noreply@anthropic.com>
</commit_message>
<xml_diff>
--- a/docs/ISP Network Observability Platform Pilot Proposal.pptx
+++ b/docs/ISP Network Observability Platform Pilot Proposal.pptx
@@ -13335,7 +13335,7 @@
                 <a:ea typeface="Inter" pitchFamily="34" charset="-122"/>
                 <a:cs typeface="Inter" pitchFamily="34" charset="-120"/>
               </a:rPr>
-              <a:t>Critical only</a:t>
+              <a:t>Real outages only</a:t>
             </a:r>
             <a:endParaRPr lang="en-US" sz="1800" dirty="0"/>
           </a:p>
@@ -13379,7 +13379,7 @@
                 <a:ea typeface="Inter" pitchFamily="34" charset="-122"/>
                 <a:cs typeface="Inter" pitchFamily="34" charset="-120"/>
               </a:rPr>
-              <a:t>Customer-facing criticals also reach the on-call phone. Warnings and monitoring-server alerts stay on Telegram.</a:t>
+              <a:t>Only outages lasting 30+ minutes reach the on-call phone, so weather fades do not. The rest stays on Telegram.</a:t>
             </a:r>
             <a:endParaRPr lang="en-US" sz="1400" dirty="0"/>
           </a:p>

</xml_diff>